<commit_message>
fix: bg_grad not rendering in win32com → replace with bg_solid for 5 slides
- Slide 01 (Cover): bg_solid(NVY) + restructured z-order with gbox last
- Slide 06 (Map Actions): bg_solid(T_DK)
- Slide 13 (Review Psychology): bg_solid(T_DK)
- Slide 19 (Action Change): bg_solid(T_DK)
- Slide 26 (CTA): bg_solid(T_DK)

Co-Authored-By: Claude Sonnet 4.6 <noreply@anthropic.com>
</commit_message>
<xml_diff>
--- a/08【MEO対策エンド資料デザイン化】/MEO対策エンド資料_v4.pptx
+++ b/08【MEO対策エンド資料デザイン化】/MEO対策エンド資料_v4.pptx
@@ -3107,6 +3107,14 @@
 <file path=ppt/slides/slide1.xml><?xml version="1.0" encoding="utf-8"?>
 <p:sld xmlns:a="http://schemas.openxmlformats.org/drawingml/2006/main" xmlns:p="http://schemas.openxmlformats.org/presentationml/2006/main" xmlns:r="http://schemas.openxmlformats.org/officeDocument/2006/relationships">
   <p:cSld>
+    <p:bg>
+      <p:bgPr>
+        <a:solidFill>
+          <a:srgbClr val="0A182C"/>
+        </a:solidFill>
+        <a:effectLst/>
+      </p:bgPr>
+    </p:bg>
     <p:spTree>
       <p:nvGrpSpPr>
         <p:cNvPr id="1" name=""/>
@@ -3116,14 +3124,151 @@
       <p:grpSpPr/>
       <p:sp>
         <p:nvSpPr>
-          <p:cNvPr id="5" name="Rectangle 4"/>
+          <p:cNvPr id="10" name="Rectangle 9"/>
           <p:cNvSpPr/>
           <p:nvPr/>
         </p:nvSpPr>
         <p:spPr>
+          <a:gradFill>
+            <a:gsLst>
+              <a:gs pos="0">
+                <a:srgbClr val="009A9A"/>
+              </a:gs>
+              <a:gs pos="100000">
+                <a:srgbClr val="3DD9E0"/>
+              </a:gs>
+            </a:gsLst>
+            <a:lin ang="5400000" scaled="0"/>
+          </a:gradFill>
+          <a:xfrm>
+            <a:off x="5119359" y="0"/>
+            <a:ext cx="7069592" cy="6858000"/>
+          </a:xfrm>
+          <a:prstGeom prst="rect">
+            <a:avLst/>
+          </a:prstGeom>
+          <a:ln>
+            <a:noFill/>
+          </a:ln>
+        </p:spPr>
+        <p:style>
+          <a:lnRef idx="1">
+            <a:schemeClr val="accent1"/>
+          </a:lnRef>
+          <a:fillRef idx="3">
+            <a:schemeClr val="accent1"/>
+          </a:fillRef>
+          <a:effectRef idx="2">
+            <a:schemeClr val="accent1"/>
+          </a:effectRef>
+          <a:fontRef idx="minor">
+            <a:schemeClr val="lt1"/>
+          </a:fontRef>
+        </p:style>
+        <p:txBody>
+          <a:bodyPr rtlCol="0" anchor="ctr"/>
+          <a:lstStyle/>
+          <a:p>
+            <a:pPr algn="ctr"/>
+          </a:p>
+        </p:txBody>
+      </p:sp>
+      <p:sp>
+        <p:nvSpPr>
+          <p:cNvPr id="2" name="Rectangle 1"/>
+          <p:cNvSpPr/>
+          <p:nvPr/>
+        </p:nvSpPr>
+        <p:spPr>
+          <a:xfrm>
+            <a:off x="0" y="0"/>
+            <a:ext cx="109728" cy="6858000"/>
+          </a:xfrm>
+          <a:prstGeom prst="rect">
+            <a:avLst/>
+          </a:prstGeom>
+          <a:solidFill>
+            <a:srgbClr val="009A9A"/>
+          </a:solidFill>
+          <a:ln>
+            <a:noFill/>
+          </a:ln>
+        </p:spPr>
+        <p:style>
+          <a:lnRef idx="1">
+            <a:schemeClr val="accent1"/>
+          </a:lnRef>
+          <a:fillRef idx="3">
+            <a:schemeClr val="accent1"/>
+          </a:fillRef>
+          <a:effectRef idx="2">
+            <a:schemeClr val="accent1"/>
+          </a:effectRef>
+          <a:fontRef idx="minor">
+            <a:schemeClr val="lt1"/>
+          </a:fontRef>
+        </p:style>
+        <p:txBody>
+          <a:bodyPr rtlCol="0" anchor="ctr"/>
+          <a:lstStyle/>
+          <a:p>
+            <a:pPr algn="ctr"/>
+          </a:p>
+        </p:txBody>
+      </p:sp>
+      <p:sp>
+        <p:nvSpPr>
+          <p:cNvPr id="3" name="Rectangle 2"/>
+          <p:cNvSpPr/>
+          <p:nvPr/>
+        </p:nvSpPr>
+        <p:spPr>
+          <a:xfrm>
+            <a:off x="0" y="4937760"/>
+            <a:ext cx="12188952" cy="1920240"/>
+          </a:xfrm>
+          <a:prstGeom prst="rect">
+            <a:avLst/>
+          </a:prstGeom>
+          <a:solidFill>
+            <a:srgbClr val="FFFFFF"/>
+          </a:solidFill>
+          <a:ln>
+            <a:noFill/>
+          </a:ln>
+        </p:spPr>
+        <p:style>
+          <a:lnRef idx="1">
+            <a:schemeClr val="accent1"/>
+          </a:lnRef>
+          <a:fillRef idx="3">
+            <a:schemeClr val="accent1"/>
+          </a:fillRef>
+          <a:effectRef idx="2">
+            <a:schemeClr val="accent1"/>
+          </a:effectRef>
+          <a:fontRef idx="minor">
+            <a:schemeClr val="lt1"/>
+          </a:fontRef>
+        </p:style>
+        <p:txBody>
+          <a:bodyPr rtlCol="0" anchor="ctr"/>
+          <a:lstStyle/>
+          <a:p>
+            <a:pPr algn="ctr"/>
+          </a:p>
+        </p:txBody>
+      </p:sp>
+      <p:sp>
+        <p:nvSpPr>
+          <p:cNvPr id="4" name="Rectangle 3"/>
+          <p:cNvSpPr/>
+          <p:nvPr/>
+        </p:nvSpPr>
+        <p:spPr>
           <a:xfrm>
             <a:off x="0" y="4800600"/>
-            <a:ext cx="12188952" cy="64008"/>
+            <a:ext cx="12188952" cy="59436"/>
           </a:xfrm>
           <a:prstGeom prst="rect">
             <a:avLst/>
@@ -3159,20 +3304,20 @@
       </p:sp>
       <p:sp>
         <p:nvSpPr>
-          <p:cNvPr id="4" name="Rectangle 3"/>
+          <p:cNvPr id="5" name="Oval 4"/>
           <p:cNvSpPr/>
           <p:nvPr/>
         </p:nvSpPr>
         <p:spPr>
           <a:xfrm>
-            <a:off x="0" y="4937760"/>
-            <a:ext cx="12188952" cy="1920240"/>
-          </a:xfrm>
-          <a:prstGeom prst="rect">
+            <a:off x="8044708" y="-914400"/>
+            <a:ext cx="4114800" cy="4114800"/>
+          </a:xfrm>
+          <a:prstGeom prst="ellipse">
             <a:avLst/>
           </a:prstGeom>
           <a:solidFill>
-            <a:srgbClr val="FFFFFF"/>
+            <a:srgbClr val="3DD9E0"/>
           </a:solidFill>
           <a:ln>
             <a:noFill/>
@@ -3202,138 +3347,46 @@
       </p:sp>
       <p:sp>
         <p:nvSpPr>
-          <p:cNvPr id="3" name="Rectangle 2"/>
-          <p:cNvSpPr/>
-          <p:nvPr/>
-        </p:nvSpPr>
-        <p:spPr>
-          <a:xfrm>
-            <a:off x="0" y="0"/>
-            <a:ext cx="91440" cy="6858000"/>
-          </a:xfrm>
-          <a:prstGeom prst="rect">
-            <a:avLst/>
-          </a:prstGeom>
-          <a:solidFill>
-            <a:srgbClr val="0A182C"/>
-          </a:solidFill>
-          <a:ln>
-            <a:noFill/>
-          </a:ln>
-        </p:spPr>
-        <p:style>
-          <a:lnRef idx="1">
-            <a:schemeClr val="accent1"/>
-          </a:lnRef>
-          <a:fillRef idx="3">
-            <a:schemeClr val="accent1"/>
-          </a:fillRef>
-          <a:effectRef idx="2">
-            <a:schemeClr val="accent1"/>
-          </a:effectRef>
-          <a:fontRef idx="minor">
-            <a:schemeClr val="lt1"/>
-          </a:fontRef>
-        </p:style>
-        <p:txBody>
-          <a:bodyPr rtlCol="0" anchor="ctr"/>
-          <a:lstStyle/>
-          <a:p>
-            <a:pPr algn="ctr"/>
-          </a:p>
-        </p:txBody>
-      </p:sp>
-      <p:sp>
-        <p:nvSpPr>
-          <p:cNvPr id="2" name="Rectangle 1"/>
-          <p:cNvSpPr/>
-          <p:nvPr/>
-        </p:nvSpPr>
-        <p:spPr>
-          <a:gradFill>
-            <a:gsLst>
-              <a:gs pos="0">
-                <a:srgbClr val="00C4CC"/>
-              </a:gs>
-              <a:gs pos="100000">
-                <a:srgbClr val="3DD9E0"/>
-              </a:gs>
-            </a:gsLst>
-            <a:lin ang="0" scaled="0"/>
-          </a:gradFill>
-          <a:xfrm>
-            <a:off x="6338255" y="0"/>
-            <a:ext cx="5850696" cy="6858000"/>
-          </a:xfrm>
-          <a:prstGeom prst="rect">
-            <a:avLst/>
-          </a:prstGeom>
-          <a:ln>
-            <a:noFill/>
-          </a:ln>
-        </p:spPr>
-        <p:style>
-          <a:lnRef idx="1">
-            <a:schemeClr val="accent1"/>
-          </a:lnRef>
-          <a:fillRef idx="3">
-            <a:schemeClr val="accent1"/>
-          </a:fillRef>
-          <a:effectRef idx="2">
-            <a:schemeClr val="accent1"/>
-          </a:effectRef>
-          <a:fontRef idx="minor">
-            <a:schemeClr val="lt1"/>
-          </a:fontRef>
-        </p:style>
-        <p:txBody>
-          <a:bodyPr rtlCol="0" anchor="ctr"/>
-          <a:lstStyle/>
-          <a:p>
-            <a:pPr algn="ctr"/>
-          </a:p>
-        </p:txBody>
-      </p:sp>
-      <p:sp>
-        <p:nvSpPr>
-          <p:cNvPr id="6" name="Oval 5"/>
-          <p:cNvSpPr/>
-          <p:nvPr/>
-        </p:nvSpPr>
-        <p:spPr>
-          <a:xfrm>
-            <a:off x="8288487" y="-1097280"/>
-            <a:ext cx="4114800" cy="4114800"/>
-          </a:xfrm>
-          <a:prstGeom prst="ellipse">
-            <a:avLst/>
-          </a:prstGeom>
-          <a:solidFill>
-            <a:srgbClr val="00C4CC"/>
-          </a:solidFill>
-          <a:ln>
-            <a:noFill/>
-          </a:ln>
-        </p:spPr>
-        <p:style>
-          <a:lnRef idx="1">
-            <a:schemeClr val="accent1"/>
-          </a:lnRef>
-          <a:fillRef idx="3">
-            <a:schemeClr val="accent1"/>
-          </a:fillRef>
-          <a:effectRef idx="2">
-            <a:schemeClr val="accent1"/>
-          </a:effectRef>
-          <a:fontRef idx="minor">
-            <a:schemeClr val="lt1"/>
-          </a:fontRef>
-        </p:style>
-        <p:txBody>
-          <a:bodyPr rtlCol="0" anchor="ctr"/>
-          <a:lstStyle/>
-          <a:p>
-            <a:pPr algn="ctr"/>
+          <p:cNvPr id="6" name="TextBox 5"/>
+          <p:cNvSpPr txBox="1"/>
+          <p:nvPr/>
+        </p:nvSpPr>
+        <p:spPr>
+          <a:xfrm>
+            <a:off x="502920" y="480060"/>
+            <a:ext cx="7557150" cy="3223260"/>
+          </a:xfrm>
+          <a:prstGeom prst="rect">
+            <a:avLst/>
+          </a:prstGeom>
+          <a:noFill/>
+        </p:spPr>
+        <p:txBody>
+          <a:bodyPr wrap="square">
+            <a:spAutoFit/>
+          </a:bodyPr>
+          <a:lstStyle/>
+          <a:p>
+            <a:pPr algn="l"/>
+            <a:r>
+              <a:rPr sz="5000" b="1">
+                <a:solidFill>
+                  <a:srgbClr val="FFFFFF"/>
+                </a:solidFill>
+              </a:rPr>
+              <a:t>MEO対策で</a:t>
+            </a:r>
+          </a:p>
+          <a:p>
+            <a:pPr algn="l"/>
+            <a:r>
+              <a:rPr sz="5000" b="1">
+                <a:solidFill>
+                  <a:srgbClr val="FFFFFF"/>
+                </a:solidFill>
+              </a:rPr>
+              <a:t>集客力を最大化する</a:t>
+            </a:r>
           </a:p>
         </p:txBody>
       </p:sp>
@@ -3345,8 +3398,8 @@
         </p:nvSpPr>
         <p:spPr>
           <a:xfrm>
-            <a:off x="457200" y="548640"/>
-            <a:ext cx="9507382" cy="2606040"/>
+            <a:off x="502920" y="3566160"/>
+            <a:ext cx="7557150" cy="1097280"/>
           </a:xfrm>
           <a:prstGeom prst="rect">
             <a:avLst/>
@@ -3361,37 +3414,60 @@
           <a:p>
             <a:pPr algn="l"/>
             <a:r>
-              <a:rPr sz="4600" b="1">
-                <a:solidFill>
-                  <a:srgbClr val="FFFFFF"/>
-                </a:solidFill>
-              </a:rPr>
-              <a:t>MEO対策で</a:t>
-            </a:r>
-          </a:p>
+              <a:rPr sz="2000" b="1">
+                <a:solidFill>
+                  <a:srgbClr val="F5C000"/>
+                </a:solidFill>
+              </a:rPr>
+              <a:t>Googleマップ集客で、売上が上がる、選ばれるお店に</a:t>
+            </a:r>
+          </a:p>
+        </p:txBody>
+      </p:sp>
+      <p:sp>
+        <p:nvSpPr>
+          <p:cNvPr id="8" name="TextBox 7"/>
+          <p:cNvSpPr txBox="1"/>
+          <p:nvPr/>
+        </p:nvSpPr>
+        <p:spPr>
+          <a:xfrm>
+            <a:off x="502920" y="5109210"/>
+            <a:ext cx="7069592" cy="548640"/>
+          </a:xfrm>
+          <a:prstGeom prst="rect">
+            <a:avLst/>
+          </a:prstGeom>
+          <a:noFill/>
+        </p:spPr>
+        <p:txBody>
+          <a:bodyPr wrap="square">
+            <a:spAutoFit/>
+          </a:bodyPr>
+          <a:lstStyle/>
           <a:p>
             <a:pPr algn="l"/>
             <a:r>
-              <a:rPr sz="4600" b="1">
-                <a:solidFill>
-                  <a:srgbClr val="FFFFFF"/>
-                </a:solidFill>
-              </a:rPr>
-              <a:t>集客力を最大化する</a:t>
-            </a:r>
-          </a:p>
-        </p:txBody>
-      </p:sp>
-      <p:sp>
-        <p:nvSpPr>
-          <p:cNvPr id="8" name="TextBox 7"/>
-          <p:cNvSpPr txBox="1"/>
-          <p:nvPr/>
-        </p:nvSpPr>
-        <p:spPr>
-          <a:xfrm>
-            <a:off x="457200" y="3429000"/>
-            <a:ext cx="9507382" cy="1234440"/>
+              <a:rPr sz="1300" b="0">
+                <a:solidFill>
+                  <a:srgbClr val="44586C"/>
+                </a:solidFill>
+              </a:rPr>
+              <a:t>MEO対策 / Googleビジネスプロフィール最適化</a:t>
+            </a:r>
+          </a:p>
+        </p:txBody>
+      </p:sp>
+      <p:sp>
+        <p:nvSpPr>
+          <p:cNvPr id="9" name="TextBox 8"/>
+          <p:cNvSpPr txBox="1"/>
+          <p:nvPr/>
+        </p:nvSpPr>
+        <p:spPr>
+          <a:xfrm>
+            <a:off x="502920" y="5726430"/>
+            <a:ext cx="7069592" cy="685800"/>
           </a:xfrm>
           <a:prstGeom prst="rect">
             <a:avLst/>
@@ -3406,75 +3482,7 @@
           <a:p>
             <a:pPr algn="l"/>
             <a:r>
-              <a:rPr sz="2000" b="1">
-                <a:solidFill>
-                  <a:srgbClr val="F5C000"/>
-                </a:solidFill>
-              </a:rPr>
-              <a:t>Googleマップ集客で、売上が上がる、選ばれるお店に</a:t>
-            </a:r>
-          </a:p>
-        </p:txBody>
-      </p:sp>
-      <p:sp>
-        <p:nvSpPr>
-          <p:cNvPr id="9" name="TextBox 8"/>
-          <p:cNvSpPr txBox="1"/>
-          <p:nvPr/>
-        </p:nvSpPr>
-        <p:spPr>
-          <a:xfrm>
-            <a:off x="457200" y="5143500"/>
-            <a:ext cx="7313371" cy="548640"/>
-          </a:xfrm>
-          <a:prstGeom prst="rect">
-            <a:avLst/>
-          </a:prstGeom>
-          <a:noFill/>
-        </p:spPr>
-        <p:txBody>
-          <a:bodyPr wrap="square">
-            <a:spAutoFit/>
-          </a:bodyPr>
-          <a:lstStyle/>
-          <a:p>
-            <a:pPr algn="l"/>
-            <a:r>
-              <a:rPr sz="1300" b="0">
-                <a:solidFill>
-                  <a:srgbClr val="44586C"/>
-                </a:solidFill>
-              </a:rPr>
-              <a:t>MEO対策 / Googleビジネスプロフィール最適化</a:t>
-            </a:r>
-          </a:p>
-        </p:txBody>
-      </p:sp>
-      <p:sp>
-        <p:nvSpPr>
-          <p:cNvPr id="10" name="TextBox 9"/>
-          <p:cNvSpPr txBox="1"/>
-          <p:nvPr/>
-        </p:nvSpPr>
-        <p:spPr>
-          <a:xfrm>
-            <a:off x="457200" y="5692140"/>
-            <a:ext cx="7313371" cy="685800"/>
-          </a:xfrm>
-          <a:prstGeom prst="rect">
-            <a:avLst/>
-          </a:prstGeom>
-          <a:noFill/>
-        </p:spPr>
-        <p:txBody>
-          <a:bodyPr wrap="square">
-            <a:spAutoFit/>
-          </a:bodyPr>
-          <a:lstStyle/>
-          <a:p>
-            <a:pPr algn="l"/>
-            <a:r>
-              <a:rPr sz="1500" b="1">
+              <a:rPr sz="1600" b="1">
                 <a:solidFill>
                   <a:srgbClr val="122234"/>
                 </a:solidFill>
@@ -3485,19 +3493,6 @@
         </p:txBody>
       </p:sp>
     </p:spTree>
-    <p:bgPr>
-      <a:gradFill>
-        <a:gsLst>
-          <a:gs pos="0">
-            <a:srgbClr val="005E6E"/>
-          </a:gs>
-          <a:gs pos="100000">
-            <a:srgbClr val="00C4CC"/>
-          </a:gs>
-        </a:gsLst>
-        <a:lin ang="0" scaled="0"/>
-      </a:gradFill>
-    </p:bgPr>
   </p:cSld>
   <p:clrMapOvr>
     <a:masterClrMapping/>
@@ -5975,6 +5970,14 @@
 <file path=ppt/slides/slide13.xml><?xml version="1.0" encoding="utf-8"?>
 <p:sld xmlns:a="http://schemas.openxmlformats.org/drawingml/2006/main" xmlns:p="http://schemas.openxmlformats.org/presentationml/2006/main" xmlns:r="http://schemas.openxmlformats.org/officeDocument/2006/relationships">
   <p:cSld>
+    <p:bg>
+      <p:bgPr>
+        <a:solidFill>
+          <a:srgbClr val="005E6E"/>
+        </a:solidFill>
+        <a:effectLst/>
+      </p:bgPr>
+    </p:bg>
     <p:spTree>
       <p:nvGrpSpPr>
         <p:cNvPr id="1" name=""/>
@@ -6536,19 +6539,6 @@
         </p:txBody>
       </p:sp>
     </p:spTree>
-    <p:bgPr>
-      <a:gradFill>
-        <a:gsLst>
-          <a:gs pos="0">
-            <a:srgbClr val="005E6E"/>
-          </a:gs>
-          <a:gs pos="100000">
-            <a:srgbClr val="009A9A"/>
-          </a:gs>
-        </a:gsLst>
-        <a:lin ang="0" scaled="0"/>
-      </a:gradFill>
-    </p:bgPr>
   </p:cSld>
   <p:clrMapOvr>
     <a:masterClrMapping/>
@@ -11203,6 +11193,14 @@
 <file path=ppt/slides/slide19.xml><?xml version="1.0" encoding="utf-8"?>
 <p:sld xmlns:a="http://schemas.openxmlformats.org/drawingml/2006/main" xmlns:p="http://schemas.openxmlformats.org/presentationml/2006/main" xmlns:r="http://schemas.openxmlformats.org/officeDocument/2006/relationships">
   <p:cSld>
+    <p:bg>
+      <p:bgPr>
+        <a:solidFill>
+          <a:srgbClr val="005E6E"/>
+        </a:solidFill>
+        <a:effectLst/>
+      </p:bgPr>
+    </p:bg>
     <p:spTree>
       <p:nvGrpSpPr>
         <p:cNvPr id="1" name=""/>
@@ -12261,19 +12259,6 @@
         </p:txBody>
       </p:sp>
     </p:spTree>
-    <p:bgPr>
-      <a:gradFill>
-        <a:gsLst>
-          <a:gs pos="0">
-            <a:srgbClr val="005E6E"/>
-          </a:gs>
-          <a:gs pos="100000">
-            <a:srgbClr val="009A9A"/>
-          </a:gs>
-        </a:gsLst>
-        <a:lin ang="5400000" scaled="0"/>
-      </a:gradFill>
-    </p:bgPr>
   </p:cSld>
   <p:clrMapOvr>
     <a:masterClrMapping/>
@@ -19808,6 +19793,14 @@
 <file path=ppt/slides/slide26.xml><?xml version="1.0" encoding="utf-8"?>
 <p:sld xmlns:a="http://schemas.openxmlformats.org/drawingml/2006/main" xmlns:p="http://schemas.openxmlformats.org/presentationml/2006/main" xmlns:r="http://schemas.openxmlformats.org/officeDocument/2006/relationships">
   <p:cSld>
+    <p:bg>
+      <p:bgPr>
+        <a:solidFill>
+          <a:srgbClr val="005E6E"/>
+        </a:solidFill>
+        <a:effectLst/>
+      </p:bgPr>
+    </p:bg>
     <p:spTree>
       <p:nvGrpSpPr>
         <p:cNvPr id="1" name=""/>
@@ -20235,19 +20228,6 @@
         </p:txBody>
       </p:sp>
     </p:spTree>
-    <p:bgPr>
-      <a:gradFill>
-        <a:gsLst>
-          <a:gs pos="0">
-            <a:srgbClr val="005E6E"/>
-          </a:gs>
-          <a:gs pos="100000">
-            <a:srgbClr val="009A9A"/>
-          </a:gs>
-        </a:gsLst>
-        <a:lin ang="0" scaled="0"/>
-      </a:gradFill>
-    </p:bgPr>
   </p:cSld>
   <p:clrMapOvr>
     <a:masterClrMapping/>
@@ -23131,6 +23111,14 @@
 <file path=ppt/slides/slide6.xml><?xml version="1.0" encoding="utf-8"?>
 <p:sld xmlns:a="http://schemas.openxmlformats.org/drawingml/2006/main" xmlns:p="http://schemas.openxmlformats.org/presentationml/2006/main" xmlns:r="http://schemas.openxmlformats.org/officeDocument/2006/relationships">
   <p:cSld>
+    <p:bg>
+      <p:bgPr>
+        <a:solidFill>
+          <a:srgbClr val="005E6E"/>
+        </a:solidFill>
+        <a:effectLst/>
+      </p:bgPr>
+    </p:bg>
     <p:spTree>
       <p:nvGrpSpPr>
         <p:cNvPr id="1" name=""/>
@@ -23917,19 +23905,6 @@
         </p:txBody>
       </p:sp>
     </p:spTree>
-    <p:bgPr>
-      <a:gradFill>
-        <a:gsLst>
-          <a:gs pos="0">
-            <a:srgbClr val="005E6E"/>
-          </a:gs>
-          <a:gs pos="100000">
-            <a:srgbClr val="009A9A"/>
-          </a:gs>
-        </a:gsLst>
-        <a:lin ang="5400000" scaled="0"/>
-      </a:gradFill>
-    </p:bgPr>
   </p:cSld>
   <p:clrMapOvr>
     <a:masterClrMapping/>

</xml_diff>